<commit_message>
Final polish of IoT presentation and speech after critic review
Co-Authored-By: Claude Opus 5.5 <noreply@anthropic.com>
Claude-Session: https://claude.ai/code/session_01XBBeEGSkQwXXyvWsro7HdT
</commit_message>
<xml_diff>
--- a/presentation-iot-streaming/Интернет вещей и анализ потоковых данных.pptx
+++ b/presentation-iot-streaming/Интернет вещей и анализ потоковых данных.pptx
@@ -1079,7 +1079,7 @@
             <a:pPr/>
             <a:r>
               <a:rPr lang="ru" dirty="0"/>
-              <a:t>Поэтому быстрая реакция, например на аварию, требует потоковой обработки, а отчёты и обучение моделей на истории удобнее строить пакетно. На практике два подхода дополняют друг друга.</a:t>
+              <a:t>Поэтому быстрая реакция, например на аварию, требует потоковой обработки, а отчёты и обучение моделей на истории удобнее выполнять пакетно. На практике два подхода дополняют друг друга.</a:t>
             </a:r>
           </a:p>
         </p:txBody>
@@ -1325,7 +1325,7 @@
             <a:pPr/>
             <a:r>
               <a:rPr lang="ru" dirty="0"/>
-              <a:t>Первый компонент: брокер сообщений, например Apache Kafka. Он принимает события от устройств и шлюзов и записывает их в журнал. Журнал хранит события долго, его можно перечитать. Брокер MQTT и Kafka относятся к разным системам, данные между ними передаёт шлюз или коннектор.</a:t>
+              <a:t>Первый компонент: брокер сообщений, например Apache Kafka. Он принимает события от устройств и шлюзов и записывает их в журнал. Журнал хранит события долго, его можно перечитать. Брокер MQTT и Kafka относятся к разным системам: данные между ними передаёт шлюз или коннектор.</a:t>
             </a:r>
           </a:p>
           <a:p>

</xml_diff>